<commit_message>
Update PPTX: add typical users to slide 3, add conclusion slide
Co-Authored-By: Claude Sonnet 4.6 <noreply@anthropic.com>
</commit_message>
<xml_diff>
--- a/reports/presentation.pptx
+++ b/reports/presentation.pptx
@@ -21,6 +21,7 @@
     <p:sldId id="269" r:id="rId20"/>
     <p:sldId id="270" r:id="rId21"/>
     <p:sldId id="271" r:id="rId22"/>
+    <p:sldId id="273" r:id="rId24"/>
     <p:sldId id="272" r:id="rId23"/>
   </p:sldIdLst>
   <p:sldSz cx="12191695" cy="6858000" type="screen4x3"/>
@@ -17721,6 +17722,1699 @@
 </p:sld>
 </file>
 
+<file path=ppt/slides/slide18.xml><?xml version="1.0" encoding="utf-8"?>
+<p:sld xmlns:a="http://schemas.openxmlformats.org/drawingml/2006/main" xmlns:p="http://schemas.openxmlformats.org/presentationml/2006/main" xmlns:r="http://schemas.openxmlformats.org/officeDocument/2006/relationships">
+  <p:cSld>
+    <p:bg>
+      <p:bgPr>
+        <a:solidFill>
+          <a:srgbClr val="0D1117"/>
+        </a:solidFill>
+        <a:effectLst/>
+      </p:bgPr>
+    </p:bg>
+    <p:spTree>
+      <p:nvGrpSpPr>
+        <p:cNvPr id="1" name=""/>
+        <p:cNvGrpSpPr/>
+        <p:nvPr/>
+      </p:nvGrpSpPr>
+      <p:grpSpPr/>
+      <p:sp>
+        <p:nvSpPr>
+          <p:cNvPr id="2" name="Rectangle 1"/>
+          <p:cNvSpPr/>
+          <p:nvPr/>
+        </p:nvSpPr>
+        <p:spPr>
+          <a:xfrm>
+            <a:off x="0" y="0"/>
+            <a:ext cx="12191695" cy="64008"/>
+          </a:xfrm>
+          <a:prstGeom prst="rect">
+            <a:avLst/>
+          </a:prstGeom>
+          <a:solidFill>
+            <a:srgbClr val="39D3C3"/>
+          </a:solidFill>
+          <a:ln>
+            <a:noFill/>
+          </a:ln>
+        </p:spPr>
+        <p:style>
+          <a:lnRef idx="1">
+            <a:schemeClr val="accent1"/>
+          </a:lnRef>
+          <a:fillRef idx="3">
+            <a:schemeClr val="accent1"/>
+          </a:fillRef>
+          <a:effectRef idx="2">
+            <a:schemeClr val="accent1"/>
+          </a:effectRef>
+          <a:fontRef idx="minor">
+            <a:schemeClr val="lt1"/>
+          </a:fontRef>
+        </p:style>
+        <p:txBody>
+          <a:bodyPr rtlCol="0" anchor="ctr"/>
+          <a:lstStyle/>
+          <a:p>
+            <a:pPr algn="ctr"/>
+          </a:p>
+        </p:txBody>
+      </p:sp>
+      <p:sp>
+        <p:nvSpPr>
+          <p:cNvPr id="3" name="Rectangle 2"/>
+          <p:cNvSpPr/>
+          <p:nvPr/>
+        </p:nvSpPr>
+        <p:spPr>
+          <a:xfrm>
+            <a:off x="365760" y="128016"/>
+            <a:ext cx="1280160" cy="292608"/>
+          </a:xfrm>
+          <a:prstGeom prst="rect">
+            <a:avLst/>
+          </a:prstGeom>
+          <a:solidFill>
+            <a:srgbClr val="39D3C3"/>
+          </a:solidFill>
+          <a:ln>
+            <a:noFill/>
+          </a:ln>
+        </p:spPr>
+        <p:style>
+          <a:lnRef idx="1">
+            <a:schemeClr val="accent1"/>
+          </a:lnRef>
+          <a:fillRef idx="3">
+            <a:schemeClr val="accent1"/>
+          </a:fillRef>
+          <a:effectRef idx="2">
+            <a:schemeClr val="accent1"/>
+          </a:effectRef>
+          <a:fontRef idx="minor">
+            <a:schemeClr val="lt1"/>
+          </a:fontRef>
+        </p:style>
+        <p:txBody>
+          <a:bodyPr rtlCol="0" anchor="ctr"/>
+          <a:lstStyle/>
+          <a:p>
+            <a:pPr algn="ctr"/>
+            <a:r>
+              <a:rPr sz="1000" b="1">
+                <a:solidFill>
+                  <a:srgbClr val="FFFFFF"/>
+                </a:solidFill>
+              </a:rPr>
+              <a:t>CONCLUSION</a:t>
+            </a:r>
+          </a:p>
+        </p:txBody>
+      </p:sp>
+      <p:sp>
+        <p:nvSpPr>
+          <p:cNvPr id="4" name="TextBox 3"/>
+          <p:cNvSpPr txBox="1"/>
+          <p:nvPr/>
+        </p:nvSpPr>
+        <p:spPr>
+          <a:xfrm>
+            <a:off x="1783080" y="128016"/>
+            <a:ext cx="10058400" cy="365760"/>
+          </a:xfrm>
+          <a:prstGeom prst="rect">
+            <a:avLst/>
+          </a:prstGeom>
+          <a:noFill/>
+        </p:spPr>
+        <p:txBody>
+          <a:bodyPr wrap="square">
+            <a:spAutoFit/>
+          </a:bodyPr>
+          <a:lstStyle/>
+          <a:p>
+            <a:pPr algn="l"/>
+            <a:r>
+              <a:rPr sz="2200" b="1" i="0">
+                <a:solidFill>
+                  <a:srgbClr val="FFFFFF"/>
+                </a:solidFill>
+              </a:rPr>
+              <a:t>Summary &amp; Lessons Learned</a:t>
+            </a:r>
+          </a:p>
+        </p:txBody>
+      </p:sp>
+      <p:sp>
+        <p:nvSpPr>
+          <p:cNvPr id="5" name="Rectangle 4"/>
+          <p:cNvSpPr/>
+          <p:nvPr/>
+        </p:nvSpPr>
+        <p:spPr>
+          <a:xfrm>
+            <a:off x="0" y="6812280"/>
+            <a:ext cx="12191695" cy="45720"/>
+          </a:xfrm>
+          <a:prstGeom prst="rect">
+            <a:avLst/>
+          </a:prstGeom>
+          <a:solidFill>
+            <a:srgbClr val="39D3C3"/>
+          </a:solidFill>
+          <a:ln>
+            <a:noFill/>
+          </a:ln>
+        </p:spPr>
+        <p:style>
+          <a:lnRef idx="1">
+            <a:schemeClr val="accent1"/>
+          </a:lnRef>
+          <a:fillRef idx="3">
+            <a:schemeClr val="accent1"/>
+          </a:fillRef>
+          <a:effectRef idx="2">
+            <a:schemeClr val="accent1"/>
+          </a:effectRef>
+          <a:fontRef idx="minor">
+            <a:schemeClr val="lt1"/>
+          </a:fontRef>
+        </p:style>
+        <p:txBody>
+          <a:bodyPr rtlCol="0" anchor="ctr"/>
+          <a:lstStyle/>
+          <a:p>
+            <a:pPr algn="ctr"/>
+          </a:p>
+        </p:txBody>
+      </p:sp>
+      <p:sp>
+        <p:nvSpPr>
+          <p:cNvPr id="6" name="Rectangle 5"/>
+          <p:cNvSpPr/>
+          <p:nvPr/>
+        </p:nvSpPr>
+        <p:spPr>
+          <a:xfrm>
+            <a:off x="320040" y="658368"/>
+            <a:ext cx="5669280" cy="5861304"/>
+          </a:xfrm>
+          <a:prstGeom prst="rect">
+            <a:avLst/>
+          </a:prstGeom>
+          <a:solidFill>
+            <a:srgbClr val="161B22"/>
+          </a:solidFill>
+          <a:ln w="9525">
+            <a:solidFill>
+              <a:srgbClr val="30363D"/>
+            </a:solidFill>
+          </a:ln>
+        </p:spPr>
+        <p:style>
+          <a:lnRef idx="1">
+            <a:schemeClr val="accent1"/>
+          </a:lnRef>
+          <a:fillRef idx="3">
+            <a:schemeClr val="accent1"/>
+          </a:fillRef>
+          <a:effectRef idx="2">
+            <a:schemeClr val="accent1"/>
+          </a:effectRef>
+          <a:fontRef idx="minor">
+            <a:schemeClr val="lt1"/>
+          </a:fontRef>
+        </p:style>
+        <p:txBody>
+          <a:bodyPr rtlCol="0" anchor="ctr"/>
+          <a:lstStyle/>
+          <a:p>
+            <a:pPr algn="ctr"/>
+          </a:p>
+        </p:txBody>
+      </p:sp>
+      <p:sp>
+        <p:nvSpPr>
+          <p:cNvPr id="7" name="Rectangle 6"/>
+          <p:cNvSpPr/>
+          <p:nvPr/>
+        </p:nvSpPr>
+        <p:spPr>
+          <a:xfrm>
+            <a:off x="320040" y="658368"/>
+            <a:ext cx="73152" cy="5861304"/>
+          </a:xfrm>
+          <a:prstGeom prst="rect">
+            <a:avLst/>
+          </a:prstGeom>
+          <a:solidFill>
+            <a:srgbClr val="39D3C3"/>
+          </a:solidFill>
+          <a:ln>
+            <a:noFill/>
+          </a:ln>
+        </p:spPr>
+        <p:style>
+          <a:lnRef idx="1">
+            <a:schemeClr val="accent1"/>
+          </a:lnRef>
+          <a:fillRef idx="3">
+            <a:schemeClr val="accent1"/>
+          </a:fillRef>
+          <a:effectRef idx="2">
+            <a:schemeClr val="accent1"/>
+          </a:effectRef>
+          <a:fontRef idx="minor">
+            <a:schemeClr val="lt1"/>
+          </a:fontRef>
+        </p:style>
+        <p:txBody>
+          <a:bodyPr rtlCol="0" anchor="ctr"/>
+          <a:lstStyle/>
+          <a:p>
+            <a:pPr algn="ctr"/>
+          </a:p>
+        </p:txBody>
+      </p:sp>
+      <p:sp>
+        <p:nvSpPr>
+          <p:cNvPr id="8" name="TextBox 7"/>
+          <p:cNvSpPr txBox="1"/>
+          <p:nvPr/>
+        </p:nvSpPr>
+        <p:spPr>
+          <a:xfrm>
+            <a:off x="530352" y="749808"/>
+            <a:ext cx="5303520" cy="347472"/>
+          </a:xfrm>
+          <a:prstGeom prst="rect">
+            <a:avLst/>
+          </a:prstGeom>
+          <a:noFill/>
+        </p:spPr>
+        <p:txBody>
+          <a:bodyPr wrap="square">
+            <a:spAutoFit/>
+          </a:bodyPr>
+          <a:lstStyle/>
+          <a:p>
+            <a:pPr algn="l"/>
+            <a:r>
+              <a:rPr sz="1300" b="1" i="0">
+                <a:solidFill>
+                  <a:srgbClr val="39D3C3"/>
+                </a:solidFill>
+              </a:rPr>
+              <a:t>What We Accomplished</a:t>
+            </a:r>
+          </a:p>
+        </p:txBody>
+      </p:sp>
+      <p:sp>
+        <p:nvSpPr>
+          <p:cNvPr id="9" name="Rectangle 8"/>
+          <p:cNvSpPr/>
+          <p:nvPr/>
+        </p:nvSpPr>
+        <p:spPr>
+          <a:xfrm>
+            <a:off x="457200" y="1188720"/>
+            <a:ext cx="5394960" cy="1115568"/>
+          </a:xfrm>
+          <a:prstGeom prst="rect">
+            <a:avLst/>
+          </a:prstGeom>
+          <a:solidFill>
+            <a:srgbClr val="1C232C"/>
+          </a:solidFill>
+          <a:ln w="9525">
+            <a:solidFill>
+              <a:srgbClr val="30363D"/>
+            </a:solidFill>
+          </a:ln>
+        </p:spPr>
+        <p:style>
+          <a:lnRef idx="1">
+            <a:schemeClr val="accent1"/>
+          </a:lnRef>
+          <a:fillRef idx="3">
+            <a:schemeClr val="accent1"/>
+          </a:fillRef>
+          <a:effectRef idx="2">
+            <a:schemeClr val="accent1"/>
+          </a:effectRef>
+          <a:fontRef idx="minor">
+            <a:schemeClr val="lt1"/>
+          </a:fontRef>
+        </p:style>
+        <p:txBody>
+          <a:bodyPr rtlCol="0" anchor="ctr"/>
+          <a:lstStyle/>
+          <a:p>
+            <a:pPr algn="ctr"/>
+          </a:p>
+        </p:txBody>
+      </p:sp>
+      <p:sp>
+        <p:nvSpPr>
+          <p:cNvPr id="10" name="Rectangle 9"/>
+          <p:cNvSpPr/>
+          <p:nvPr/>
+        </p:nvSpPr>
+        <p:spPr>
+          <a:xfrm>
+            <a:off x="457200" y="1188720"/>
+            <a:ext cx="73152" cy="1115568"/>
+          </a:xfrm>
+          <a:prstGeom prst="rect">
+            <a:avLst/>
+          </a:prstGeom>
+          <a:solidFill>
+            <a:srgbClr val="58A6FF"/>
+          </a:solidFill>
+          <a:ln>
+            <a:noFill/>
+          </a:ln>
+        </p:spPr>
+        <p:style>
+          <a:lnRef idx="1">
+            <a:schemeClr val="accent1"/>
+          </a:lnRef>
+          <a:fillRef idx="3">
+            <a:schemeClr val="accent1"/>
+          </a:fillRef>
+          <a:effectRef idx="2">
+            <a:schemeClr val="accent1"/>
+          </a:effectRef>
+          <a:fontRef idx="minor">
+            <a:schemeClr val="lt1"/>
+          </a:fontRef>
+        </p:style>
+        <p:txBody>
+          <a:bodyPr rtlCol="0" anchor="ctr"/>
+          <a:lstStyle/>
+          <a:p>
+            <a:pPr algn="ctr"/>
+          </a:p>
+        </p:txBody>
+      </p:sp>
+      <p:sp>
+        <p:nvSpPr>
+          <p:cNvPr id="11" name="TextBox 10"/>
+          <p:cNvSpPr txBox="1"/>
+          <p:nvPr/>
+        </p:nvSpPr>
+        <p:spPr>
+          <a:xfrm>
+            <a:off x="658368" y="1280160"/>
+            <a:ext cx="5029200" cy="347472"/>
+          </a:xfrm>
+          <a:prstGeom prst="rect">
+            <a:avLst/>
+          </a:prstGeom>
+          <a:noFill/>
+        </p:spPr>
+        <p:txBody>
+          <a:bodyPr wrap="square">
+            <a:spAutoFit/>
+          </a:bodyPr>
+          <a:lstStyle/>
+          <a:p>
+            <a:pPr algn="l"/>
+            <a:r>
+              <a:rPr sz="1300" b="1" i="0">
+                <a:solidFill>
+                  <a:srgbClr val="58A6FF"/>
+                </a:solidFill>
+              </a:rPr>
+              <a:t>2.1  Blackbox</a:t>
+            </a:r>
+          </a:p>
+        </p:txBody>
+      </p:sp>
+      <p:sp>
+        <p:nvSpPr>
+          <p:cNvPr id="12" name="TextBox 11"/>
+          <p:cNvSpPr txBox="1"/>
+          <p:nvPr/>
+        </p:nvSpPr>
+        <p:spPr>
+          <a:xfrm>
+            <a:off x="658368" y="1664208"/>
+            <a:ext cx="5029200" cy="566928"/>
+          </a:xfrm>
+          <a:prstGeom prst="rect">
+            <a:avLst/>
+          </a:prstGeom>
+          <a:noFill/>
+        </p:spPr>
+        <p:txBody>
+          <a:bodyPr wrap="square">
+            <a:spAutoFit/>
+          </a:bodyPr>
+          <a:lstStyle/>
+          <a:p>
+            <a:pPr algn="l"/>
+            <a:r>
+              <a:rPr sz="1100" b="0" i="0">
+                <a:solidFill>
+                  <a:srgbClr val="FFFFFF"/>
+                </a:solidFill>
+              </a:rPr>
+              <a:t>117 tests — EP, BA, EG, CT
+2 real bugs found via Error Guessing</a:t>
+            </a:r>
+          </a:p>
+        </p:txBody>
+      </p:sp>
+      <p:sp>
+        <p:nvSpPr>
+          <p:cNvPr id="13" name="Rectangle 12"/>
+          <p:cNvSpPr/>
+          <p:nvPr/>
+        </p:nvSpPr>
+        <p:spPr>
+          <a:xfrm>
+            <a:off x="457200" y="2450592"/>
+            <a:ext cx="5394960" cy="1115568"/>
+          </a:xfrm>
+          <a:prstGeom prst="rect">
+            <a:avLst/>
+          </a:prstGeom>
+          <a:solidFill>
+            <a:srgbClr val="1C232C"/>
+          </a:solidFill>
+          <a:ln w="9525">
+            <a:solidFill>
+              <a:srgbClr val="30363D"/>
+            </a:solidFill>
+          </a:ln>
+        </p:spPr>
+        <p:style>
+          <a:lnRef idx="1">
+            <a:schemeClr val="accent1"/>
+          </a:lnRef>
+          <a:fillRef idx="3">
+            <a:schemeClr val="accent1"/>
+          </a:fillRef>
+          <a:effectRef idx="2">
+            <a:schemeClr val="accent1"/>
+          </a:effectRef>
+          <a:fontRef idx="minor">
+            <a:schemeClr val="lt1"/>
+          </a:fontRef>
+        </p:style>
+        <p:txBody>
+          <a:bodyPr rtlCol="0" anchor="ctr"/>
+          <a:lstStyle/>
+          <a:p>
+            <a:pPr algn="ctr"/>
+          </a:p>
+        </p:txBody>
+      </p:sp>
+      <p:sp>
+        <p:nvSpPr>
+          <p:cNvPr id="14" name="Rectangle 13"/>
+          <p:cNvSpPr/>
+          <p:nvPr/>
+        </p:nvSpPr>
+        <p:spPr>
+          <a:xfrm>
+            <a:off x="457200" y="2450592"/>
+            <a:ext cx="73152" cy="1115568"/>
+          </a:xfrm>
+          <a:prstGeom prst="rect">
+            <a:avLst/>
+          </a:prstGeom>
+          <a:solidFill>
+            <a:srgbClr val="3FB950"/>
+          </a:solidFill>
+          <a:ln>
+            <a:noFill/>
+          </a:ln>
+        </p:spPr>
+        <p:style>
+          <a:lnRef idx="1">
+            <a:schemeClr val="accent1"/>
+          </a:lnRef>
+          <a:fillRef idx="3">
+            <a:schemeClr val="accent1"/>
+          </a:fillRef>
+          <a:effectRef idx="2">
+            <a:schemeClr val="accent1"/>
+          </a:effectRef>
+          <a:fontRef idx="minor">
+            <a:schemeClr val="lt1"/>
+          </a:fontRef>
+        </p:style>
+        <p:txBody>
+          <a:bodyPr rtlCol="0" anchor="ctr"/>
+          <a:lstStyle/>
+          <a:p>
+            <a:pPr algn="ctr"/>
+          </a:p>
+        </p:txBody>
+      </p:sp>
+      <p:sp>
+        <p:nvSpPr>
+          <p:cNvPr id="15" name="TextBox 14"/>
+          <p:cNvSpPr txBox="1"/>
+          <p:nvPr/>
+        </p:nvSpPr>
+        <p:spPr>
+          <a:xfrm>
+            <a:off x="658368" y="2542032"/>
+            <a:ext cx="5029200" cy="347472"/>
+          </a:xfrm>
+          <a:prstGeom prst="rect">
+            <a:avLst/>
+          </a:prstGeom>
+          <a:noFill/>
+        </p:spPr>
+        <p:txBody>
+          <a:bodyPr wrap="square">
+            <a:spAutoFit/>
+          </a:bodyPr>
+          <a:lstStyle/>
+          <a:p>
+            <a:pPr algn="l"/>
+            <a:r>
+              <a:rPr sz="1300" b="1" i="0">
+                <a:solidFill>
+                  <a:srgbClr val="3FB950"/>
+                </a:solidFill>
+              </a:rPr>
+              <a:t>2.2  Whitebox</a:t>
+            </a:r>
+          </a:p>
+        </p:txBody>
+      </p:sp>
+      <p:sp>
+        <p:nvSpPr>
+          <p:cNvPr id="16" name="TextBox 15"/>
+          <p:cNvSpPr txBox="1"/>
+          <p:nvPr/>
+        </p:nvSpPr>
+        <p:spPr>
+          <a:xfrm>
+            <a:off x="658368" y="2926080"/>
+            <a:ext cx="5029200" cy="566928"/>
+          </a:xfrm>
+          <a:prstGeom prst="rect">
+            <a:avLst/>
+          </a:prstGeom>
+          <a:noFill/>
+        </p:spPr>
+        <p:txBody>
+          <a:bodyPr wrap="square">
+            <a:spAutoFit/>
+          </a:bodyPr>
+          <a:lstStyle/>
+          <a:p>
+            <a:pPr algn="l"/>
+            <a:r>
+              <a:rPr sz="1100" b="0" i="0">
+                <a:solidFill>
+                  <a:srgbClr val="FFFFFF"/>
+                </a:solidFill>
+              </a:rPr>
+              <a:t>86 unit + 21 integration tests
+89% branch coverage (goal: 80%+)</a:t>
+            </a:r>
+          </a:p>
+        </p:txBody>
+      </p:sp>
+      <p:sp>
+        <p:nvSpPr>
+          <p:cNvPr id="17" name="Rectangle 16"/>
+          <p:cNvSpPr/>
+          <p:nvPr/>
+        </p:nvSpPr>
+        <p:spPr>
+          <a:xfrm>
+            <a:off x="457200" y="3712464"/>
+            <a:ext cx="5394960" cy="1115568"/>
+          </a:xfrm>
+          <a:prstGeom prst="rect">
+            <a:avLst/>
+          </a:prstGeom>
+          <a:solidFill>
+            <a:srgbClr val="1C232C"/>
+          </a:solidFill>
+          <a:ln w="9525">
+            <a:solidFill>
+              <a:srgbClr val="30363D"/>
+            </a:solidFill>
+          </a:ln>
+        </p:spPr>
+        <p:style>
+          <a:lnRef idx="1">
+            <a:schemeClr val="accent1"/>
+          </a:lnRef>
+          <a:fillRef idx="3">
+            <a:schemeClr val="accent1"/>
+          </a:fillRef>
+          <a:effectRef idx="2">
+            <a:schemeClr val="accent1"/>
+          </a:effectRef>
+          <a:fontRef idx="minor">
+            <a:schemeClr val="lt1"/>
+          </a:fontRef>
+        </p:style>
+        <p:txBody>
+          <a:bodyPr rtlCol="0" anchor="ctr"/>
+          <a:lstStyle/>
+          <a:p>
+            <a:pPr algn="ctr"/>
+          </a:p>
+        </p:txBody>
+      </p:sp>
+      <p:sp>
+        <p:nvSpPr>
+          <p:cNvPr id="18" name="Rectangle 17"/>
+          <p:cNvSpPr/>
+          <p:nvPr/>
+        </p:nvSpPr>
+        <p:spPr>
+          <a:xfrm>
+            <a:off x="457200" y="3712464"/>
+            <a:ext cx="73152" cy="1115568"/>
+          </a:xfrm>
+          <a:prstGeom prst="rect">
+            <a:avLst/>
+          </a:prstGeom>
+          <a:solidFill>
+            <a:srgbClr val="E3B341"/>
+          </a:solidFill>
+          <a:ln>
+            <a:noFill/>
+          </a:ln>
+        </p:spPr>
+        <p:style>
+          <a:lnRef idx="1">
+            <a:schemeClr val="accent1"/>
+          </a:lnRef>
+          <a:fillRef idx="3">
+            <a:schemeClr val="accent1"/>
+          </a:fillRef>
+          <a:effectRef idx="2">
+            <a:schemeClr val="accent1"/>
+          </a:effectRef>
+          <a:fontRef idx="minor">
+            <a:schemeClr val="lt1"/>
+          </a:fontRef>
+        </p:style>
+        <p:txBody>
+          <a:bodyPr rtlCol="0" anchor="ctr"/>
+          <a:lstStyle/>
+          <a:p>
+            <a:pPr algn="ctr"/>
+          </a:p>
+        </p:txBody>
+      </p:sp>
+      <p:sp>
+        <p:nvSpPr>
+          <p:cNvPr id="19" name="TextBox 18"/>
+          <p:cNvSpPr txBox="1"/>
+          <p:nvPr/>
+        </p:nvSpPr>
+        <p:spPr>
+          <a:xfrm>
+            <a:off x="658368" y="3803904"/>
+            <a:ext cx="5029200" cy="347472"/>
+          </a:xfrm>
+          <a:prstGeom prst="rect">
+            <a:avLst/>
+          </a:prstGeom>
+          <a:noFill/>
+        </p:spPr>
+        <p:txBody>
+          <a:bodyPr wrap="square">
+            <a:spAutoFit/>
+          </a:bodyPr>
+          <a:lstStyle/>
+          <a:p>
+            <a:pPr algn="l"/>
+            <a:r>
+              <a:rPr sz="1300" b="1" i="0">
+                <a:solidFill>
+                  <a:srgbClr val="E3B341"/>
+                </a:solidFill>
+              </a:rPr>
+              <a:t>2.3  Mutation</a:t>
+            </a:r>
+          </a:p>
+        </p:txBody>
+      </p:sp>
+      <p:sp>
+        <p:nvSpPr>
+          <p:cNvPr id="20" name="TextBox 19"/>
+          <p:cNvSpPr txBox="1"/>
+          <p:nvPr/>
+        </p:nvSpPr>
+        <p:spPr>
+          <a:xfrm>
+            <a:off x="658368" y="4187952"/>
+            <a:ext cx="5029200" cy="566928"/>
+          </a:xfrm>
+          <a:prstGeom prst="rect">
+            <a:avLst/>
+          </a:prstGeom>
+          <a:noFill/>
+        </p:spPr>
+        <p:txBody>
+          <a:bodyPr wrap="square">
+            <a:spAutoFit/>
+          </a:bodyPr>
+          <a:lstStyle/>
+          <a:p>
+            <a:pPr algn="l"/>
+            <a:r>
+              <a:rPr sz="1100" b="0" i="0">
+                <a:solidFill>
+                  <a:srgbClr val="FFFFFF"/>
+                </a:solidFill>
+              </a:rPr>
+              <a:t>73 precision tests written
+81.6% kill rate (goal: 80%+)</a:t>
+            </a:r>
+          </a:p>
+        </p:txBody>
+      </p:sp>
+      <p:sp>
+        <p:nvSpPr>
+          <p:cNvPr id="21" name="Rectangle 20"/>
+          <p:cNvSpPr/>
+          <p:nvPr/>
+        </p:nvSpPr>
+        <p:spPr>
+          <a:xfrm>
+            <a:off x="457200" y="4974336"/>
+            <a:ext cx="5394960" cy="1115568"/>
+          </a:xfrm>
+          <a:prstGeom prst="rect">
+            <a:avLst/>
+          </a:prstGeom>
+          <a:solidFill>
+            <a:srgbClr val="1C232C"/>
+          </a:solidFill>
+          <a:ln w="9525">
+            <a:solidFill>
+              <a:srgbClr val="30363D"/>
+            </a:solidFill>
+          </a:ln>
+        </p:spPr>
+        <p:style>
+          <a:lnRef idx="1">
+            <a:schemeClr val="accent1"/>
+          </a:lnRef>
+          <a:fillRef idx="3">
+            <a:schemeClr val="accent1"/>
+          </a:fillRef>
+          <a:effectRef idx="2">
+            <a:schemeClr val="accent1"/>
+          </a:effectRef>
+          <a:fontRef idx="minor">
+            <a:schemeClr val="lt1"/>
+          </a:fontRef>
+        </p:style>
+        <p:txBody>
+          <a:bodyPr rtlCol="0" anchor="ctr"/>
+          <a:lstStyle/>
+          <a:p>
+            <a:pPr algn="ctr"/>
+          </a:p>
+        </p:txBody>
+      </p:sp>
+      <p:sp>
+        <p:nvSpPr>
+          <p:cNvPr id="22" name="Rectangle 21"/>
+          <p:cNvSpPr/>
+          <p:nvPr/>
+        </p:nvSpPr>
+        <p:spPr>
+          <a:xfrm>
+            <a:off x="457200" y="4974336"/>
+            <a:ext cx="73152" cy="1115568"/>
+          </a:xfrm>
+          <a:prstGeom prst="rect">
+            <a:avLst/>
+          </a:prstGeom>
+          <a:solidFill>
+            <a:srgbClr val="BC8CFF"/>
+          </a:solidFill>
+          <a:ln>
+            <a:noFill/>
+          </a:ln>
+        </p:spPr>
+        <p:style>
+          <a:lnRef idx="1">
+            <a:schemeClr val="accent1"/>
+          </a:lnRef>
+          <a:fillRef idx="3">
+            <a:schemeClr val="accent1"/>
+          </a:fillRef>
+          <a:effectRef idx="2">
+            <a:schemeClr val="accent1"/>
+          </a:effectRef>
+          <a:fontRef idx="minor">
+            <a:schemeClr val="lt1"/>
+          </a:fontRef>
+        </p:style>
+        <p:txBody>
+          <a:bodyPr rtlCol="0" anchor="ctr"/>
+          <a:lstStyle/>
+          <a:p>
+            <a:pPr algn="ctr"/>
+          </a:p>
+        </p:txBody>
+      </p:sp>
+      <p:sp>
+        <p:nvSpPr>
+          <p:cNvPr id="23" name="TextBox 22"/>
+          <p:cNvSpPr txBox="1"/>
+          <p:nvPr/>
+        </p:nvSpPr>
+        <p:spPr>
+          <a:xfrm>
+            <a:off x="658368" y="5065776"/>
+            <a:ext cx="5029200" cy="347472"/>
+          </a:xfrm>
+          <a:prstGeom prst="rect">
+            <a:avLst/>
+          </a:prstGeom>
+          <a:noFill/>
+        </p:spPr>
+        <p:txBody>
+          <a:bodyPr wrap="square">
+            <a:spAutoFit/>
+          </a:bodyPr>
+          <a:lstStyle/>
+          <a:p>
+            <a:pPr algn="l"/>
+            <a:r>
+              <a:rPr sz="1300" b="1" i="0">
+                <a:solidFill>
+                  <a:srgbClr val="BC8CFF"/>
+                </a:solidFill>
+              </a:rPr>
+              <a:t>2.4  CLI</a:t>
+            </a:r>
+          </a:p>
+        </p:txBody>
+      </p:sp>
+      <p:sp>
+        <p:nvSpPr>
+          <p:cNvPr id="24" name="TextBox 23"/>
+          <p:cNvSpPr txBox="1"/>
+          <p:nvPr/>
+        </p:nvSpPr>
+        <p:spPr>
+          <a:xfrm>
+            <a:off x="658368" y="5449824"/>
+            <a:ext cx="5029200" cy="566928"/>
+          </a:xfrm>
+          <a:prstGeom prst="rect">
+            <a:avLst/>
+          </a:prstGeom>
+          <a:noFill/>
+        </p:spPr>
+        <p:txBody>
+          <a:bodyPr wrap="square">
+            <a:spAutoFit/>
+          </a:bodyPr>
+          <a:lstStyle/>
+          <a:p>
+            <a:pPr algn="l"/>
+            <a:r>
+              <a:rPr sz="1100" b="0" i="0">
+                <a:solidFill>
+                  <a:srgbClr val="FFFFFF"/>
+                </a:solidFill>
+              </a:rPr>
+              <a:t>27 tests — Tier 1 subprocess
++ Tier 2 PTY for curses flags</a:t>
+            </a:r>
+          </a:p>
+        </p:txBody>
+      </p:sp>
+      <p:sp>
+        <p:nvSpPr>
+          <p:cNvPr id="25" name="Rectangle 24"/>
+          <p:cNvSpPr/>
+          <p:nvPr/>
+        </p:nvSpPr>
+        <p:spPr>
+          <a:xfrm>
+            <a:off x="6172200" y="658368"/>
+            <a:ext cx="5715000" cy="5861304"/>
+          </a:xfrm>
+          <a:prstGeom prst="rect">
+            <a:avLst/>
+          </a:prstGeom>
+          <a:solidFill>
+            <a:srgbClr val="161B22"/>
+          </a:solidFill>
+          <a:ln w="9525">
+            <a:solidFill>
+              <a:srgbClr val="30363D"/>
+            </a:solidFill>
+          </a:ln>
+        </p:spPr>
+        <p:style>
+          <a:lnRef idx="1">
+            <a:schemeClr val="accent1"/>
+          </a:lnRef>
+          <a:fillRef idx="3">
+            <a:schemeClr val="accent1"/>
+          </a:fillRef>
+          <a:effectRef idx="2">
+            <a:schemeClr val="accent1"/>
+          </a:effectRef>
+          <a:fontRef idx="minor">
+            <a:schemeClr val="lt1"/>
+          </a:fontRef>
+        </p:style>
+        <p:txBody>
+          <a:bodyPr rtlCol="0" anchor="ctr"/>
+          <a:lstStyle/>
+          <a:p>
+            <a:pPr algn="ctr"/>
+          </a:p>
+        </p:txBody>
+      </p:sp>
+      <p:sp>
+        <p:nvSpPr>
+          <p:cNvPr id="26" name="Rectangle 25"/>
+          <p:cNvSpPr/>
+          <p:nvPr/>
+        </p:nvSpPr>
+        <p:spPr>
+          <a:xfrm>
+            <a:off x="6172200" y="658368"/>
+            <a:ext cx="73152" cy="5861304"/>
+          </a:xfrm>
+          <a:prstGeom prst="rect">
+            <a:avLst/>
+          </a:prstGeom>
+          <a:solidFill>
+            <a:srgbClr val="3FB950"/>
+          </a:solidFill>
+          <a:ln>
+            <a:noFill/>
+          </a:ln>
+        </p:spPr>
+        <p:style>
+          <a:lnRef idx="1">
+            <a:schemeClr val="accent1"/>
+          </a:lnRef>
+          <a:fillRef idx="3">
+            <a:schemeClr val="accent1"/>
+          </a:fillRef>
+          <a:effectRef idx="2">
+            <a:schemeClr val="accent1"/>
+          </a:effectRef>
+          <a:fontRef idx="minor">
+            <a:schemeClr val="lt1"/>
+          </a:fontRef>
+        </p:style>
+        <p:txBody>
+          <a:bodyPr rtlCol="0" anchor="ctr"/>
+          <a:lstStyle/>
+          <a:p>
+            <a:pPr algn="ctr"/>
+          </a:p>
+        </p:txBody>
+      </p:sp>
+      <p:sp>
+        <p:nvSpPr>
+          <p:cNvPr id="27" name="TextBox 26"/>
+          <p:cNvSpPr txBox="1"/>
+          <p:nvPr/>
+        </p:nvSpPr>
+        <p:spPr>
+          <a:xfrm>
+            <a:off x="6382512" y="749808"/>
+            <a:ext cx="5394960" cy="347472"/>
+          </a:xfrm>
+          <a:prstGeom prst="rect">
+            <a:avLst/>
+          </a:prstGeom>
+          <a:noFill/>
+        </p:spPr>
+        <p:txBody>
+          <a:bodyPr wrap="square">
+            <a:spAutoFit/>
+          </a:bodyPr>
+          <a:lstStyle/>
+          <a:p>
+            <a:pPr algn="l"/>
+            <a:r>
+              <a:rPr sz="1300" b="1" i="0">
+                <a:solidFill>
+                  <a:srgbClr val="3FB950"/>
+                </a:solidFill>
+              </a:rPr>
+              <a:t>Lessons Learned</a:t>
+            </a:r>
+          </a:p>
+        </p:txBody>
+      </p:sp>
+      <p:sp>
+        <p:nvSpPr>
+          <p:cNvPr id="28" name="Rectangle 27"/>
+          <p:cNvSpPr/>
+          <p:nvPr/>
+        </p:nvSpPr>
+        <p:spPr>
+          <a:xfrm>
+            <a:off x="6309360" y="1188720"/>
+            <a:ext cx="5440680" cy="1115568"/>
+          </a:xfrm>
+          <a:prstGeom prst="rect">
+            <a:avLst/>
+          </a:prstGeom>
+          <a:solidFill>
+            <a:srgbClr val="1C232C"/>
+          </a:solidFill>
+          <a:ln w="9525">
+            <a:solidFill>
+              <a:srgbClr val="30363D"/>
+            </a:solidFill>
+          </a:ln>
+        </p:spPr>
+        <p:style>
+          <a:lnRef idx="1">
+            <a:schemeClr val="accent1"/>
+          </a:lnRef>
+          <a:fillRef idx="3">
+            <a:schemeClr val="accent1"/>
+          </a:fillRef>
+          <a:effectRef idx="2">
+            <a:schemeClr val="accent1"/>
+          </a:effectRef>
+          <a:fontRef idx="minor">
+            <a:schemeClr val="lt1"/>
+          </a:fontRef>
+        </p:style>
+        <p:txBody>
+          <a:bodyPr rtlCol="0" anchor="ctr"/>
+          <a:lstStyle/>
+          <a:p>
+            <a:pPr algn="ctr"/>
+          </a:p>
+        </p:txBody>
+      </p:sp>
+      <p:sp>
+        <p:nvSpPr>
+          <p:cNvPr id="29" name="Rectangle 28"/>
+          <p:cNvSpPr/>
+          <p:nvPr/>
+        </p:nvSpPr>
+        <p:spPr>
+          <a:xfrm>
+            <a:off x="6309360" y="1188720"/>
+            <a:ext cx="73152" cy="1115568"/>
+          </a:xfrm>
+          <a:prstGeom prst="rect">
+            <a:avLst/>
+          </a:prstGeom>
+          <a:solidFill>
+            <a:srgbClr val="F85149"/>
+          </a:solidFill>
+          <a:ln>
+            <a:noFill/>
+          </a:ln>
+        </p:spPr>
+        <p:style>
+          <a:lnRef idx="1">
+            <a:schemeClr val="accent1"/>
+          </a:lnRef>
+          <a:fillRef idx="3">
+            <a:schemeClr val="accent1"/>
+          </a:fillRef>
+          <a:effectRef idx="2">
+            <a:schemeClr val="accent1"/>
+          </a:effectRef>
+          <a:fontRef idx="minor">
+            <a:schemeClr val="lt1"/>
+          </a:fontRef>
+        </p:style>
+        <p:txBody>
+          <a:bodyPr rtlCol="0" anchor="ctr"/>
+          <a:lstStyle/>
+          <a:p>
+            <a:pPr algn="ctr"/>
+          </a:p>
+        </p:txBody>
+      </p:sp>
+      <p:sp>
+        <p:nvSpPr>
+          <p:cNvPr id="30" name="TextBox 29"/>
+          <p:cNvSpPr txBox="1"/>
+          <p:nvPr/>
+        </p:nvSpPr>
+        <p:spPr>
+          <a:xfrm>
+            <a:off x="6510528" y="1280160"/>
+            <a:ext cx="5120640" cy="347472"/>
+          </a:xfrm>
+          <a:prstGeom prst="rect">
+            <a:avLst/>
+          </a:prstGeom>
+          <a:noFill/>
+        </p:spPr>
+        <p:txBody>
+          <a:bodyPr wrap="square">
+            <a:spAutoFit/>
+          </a:bodyPr>
+          <a:lstStyle/>
+          <a:p>
+            <a:pPr algn="l"/>
+            <a:r>
+              <a:rPr sz="1200" b="1" i="0">
+                <a:solidFill>
+                  <a:srgbClr val="F85149"/>
+                </a:solidFill>
+              </a:rPr>
+              <a:t>EG finds real bugs that EP &amp; BA miss</a:t>
+            </a:r>
+          </a:p>
+        </p:txBody>
+      </p:sp>
+      <p:sp>
+        <p:nvSpPr>
+          <p:cNvPr id="31" name="TextBox 30"/>
+          <p:cNvSpPr txBox="1"/>
+          <p:nvPr/>
+        </p:nvSpPr>
+        <p:spPr>
+          <a:xfrm>
+            <a:off x="6510528" y="1664208"/>
+            <a:ext cx="5120640" cy="566928"/>
+          </a:xfrm>
+          <a:prstGeom prst="rect">
+            <a:avLst/>
+          </a:prstGeom>
+          <a:noFill/>
+        </p:spPr>
+        <p:txBody>
+          <a:bodyPr wrap="square">
+            <a:spAutoFit/>
+          </a:bodyPr>
+          <a:lstStyle/>
+          <a:p>
+            <a:pPr algn="l"/>
+            <a:r>
+              <a:rPr sz="1000" b="0" i="0">
+                <a:solidFill>
+                  <a:srgbClr val="89939E"/>
+                </a:solidFill>
+              </a:rPr>
+              <a:t>Both faults were found by guessing bad inputs — not by systematic partitioning.</a:t>
+            </a:r>
+          </a:p>
+        </p:txBody>
+      </p:sp>
+      <p:sp>
+        <p:nvSpPr>
+          <p:cNvPr id="32" name="Rectangle 31"/>
+          <p:cNvSpPr/>
+          <p:nvPr/>
+        </p:nvSpPr>
+        <p:spPr>
+          <a:xfrm>
+            <a:off x="6309360" y="2450592"/>
+            <a:ext cx="5440680" cy="1115568"/>
+          </a:xfrm>
+          <a:prstGeom prst="rect">
+            <a:avLst/>
+          </a:prstGeom>
+          <a:solidFill>
+            <a:srgbClr val="1C232C"/>
+          </a:solidFill>
+          <a:ln w="9525">
+            <a:solidFill>
+              <a:srgbClr val="30363D"/>
+            </a:solidFill>
+          </a:ln>
+        </p:spPr>
+        <p:style>
+          <a:lnRef idx="1">
+            <a:schemeClr val="accent1"/>
+          </a:lnRef>
+          <a:fillRef idx="3">
+            <a:schemeClr val="accent1"/>
+          </a:fillRef>
+          <a:effectRef idx="2">
+            <a:schemeClr val="accent1"/>
+          </a:effectRef>
+          <a:fontRef idx="minor">
+            <a:schemeClr val="lt1"/>
+          </a:fontRef>
+        </p:style>
+        <p:txBody>
+          <a:bodyPr rtlCol="0" anchor="ctr"/>
+          <a:lstStyle/>
+          <a:p>
+            <a:pPr algn="ctr"/>
+          </a:p>
+        </p:txBody>
+      </p:sp>
+      <p:sp>
+        <p:nvSpPr>
+          <p:cNvPr id="33" name="Rectangle 32"/>
+          <p:cNvSpPr/>
+          <p:nvPr/>
+        </p:nvSpPr>
+        <p:spPr>
+          <a:xfrm>
+            <a:off x="6309360" y="2450592"/>
+            <a:ext cx="73152" cy="1115568"/>
+          </a:xfrm>
+          <a:prstGeom prst="rect">
+            <a:avLst/>
+          </a:prstGeom>
+          <a:solidFill>
+            <a:srgbClr val="3FB950"/>
+          </a:solidFill>
+          <a:ln>
+            <a:noFill/>
+          </a:ln>
+        </p:spPr>
+        <p:style>
+          <a:lnRef idx="1">
+            <a:schemeClr val="accent1"/>
+          </a:lnRef>
+          <a:fillRef idx="3">
+            <a:schemeClr val="accent1"/>
+          </a:fillRef>
+          <a:effectRef idx="2">
+            <a:schemeClr val="accent1"/>
+          </a:effectRef>
+          <a:fontRef idx="minor">
+            <a:schemeClr val="lt1"/>
+          </a:fontRef>
+        </p:style>
+        <p:txBody>
+          <a:bodyPr rtlCol="0" anchor="ctr"/>
+          <a:lstStyle/>
+          <a:p>
+            <a:pPr algn="ctr"/>
+          </a:p>
+        </p:txBody>
+      </p:sp>
+      <p:sp>
+        <p:nvSpPr>
+          <p:cNvPr id="34" name="TextBox 33"/>
+          <p:cNvSpPr txBox="1"/>
+          <p:nvPr/>
+        </p:nvSpPr>
+        <p:spPr>
+          <a:xfrm>
+            <a:off x="6510528" y="2542032"/>
+            <a:ext cx="5120640" cy="347472"/>
+          </a:xfrm>
+          <a:prstGeom prst="rect">
+            <a:avLst/>
+          </a:prstGeom>
+          <a:noFill/>
+        </p:spPr>
+        <p:txBody>
+          <a:bodyPr wrap="square">
+            <a:spAutoFit/>
+          </a:bodyPr>
+          <a:lstStyle/>
+          <a:p>
+            <a:pPr algn="l"/>
+            <a:r>
+              <a:rPr sz="1200" b="1" i="0">
+                <a:solidFill>
+                  <a:srgbClr val="3FB950"/>
+                </a:solidFill>
+              </a:rPr>
+              <a:t>Coverage ≠ confidence</a:t>
+            </a:r>
+          </a:p>
+        </p:txBody>
+      </p:sp>
+      <p:sp>
+        <p:nvSpPr>
+          <p:cNvPr id="35" name="TextBox 34"/>
+          <p:cNvSpPr txBox="1"/>
+          <p:nvPr/>
+        </p:nvSpPr>
+        <p:spPr>
+          <a:xfrm>
+            <a:off x="6510528" y="2926080"/>
+            <a:ext cx="5120640" cy="566928"/>
+          </a:xfrm>
+          <a:prstGeom prst="rect">
+            <a:avLst/>
+          </a:prstGeom>
+          <a:noFill/>
+        </p:spPr>
+        <p:txBody>
+          <a:bodyPr wrap="square">
+            <a:spAutoFit/>
+          </a:bodyPr>
+          <a:lstStyle/>
+          <a:p>
+            <a:pPr algn="l"/>
+            <a:r>
+              <a:rPr sz="1000" b="0" i="0">
+                <a:solidFill>
+                  <a:srgbClr val="89939E"/>
+                </a:solidFill>
+              </a:rPr>
+              <a:t>89% branch coverage still left 144 surviving mutants. Coverage shows execution, not verification.</a:t>
+            </a:r>
+          </a:p>
+        </p:txBody>
+      </p:sp>
+      <p:sp>
+        <p:nvSpPr>
+          <p:cNvPr id="36" name="Rectangle 35"/>
+          <p:cNvSpPr/>
+          <p:nvPr/>
+        </p:nvSpPr>
+        <p:spPr>
+          <a:xfrm>
+            <a:off x="6309360" y="3712464"/>
+            <a:ext cx="5440680" cy="1115568"/>
+          </a:xfrm>
+          <a:prstGeom prst="rect">
+            <a:avLst/>
+          </a:prstGeom>
+          <a:solidFill>
+            <a:srgbClr val="1C232C"/>
+          </a:solidFill>
+          <a:ln w="9525">
+            <a:solidFill>
+              <a:srgbClr val="30363D"/>
+            </a:solidFill>
+          </a:ln>
+        </p:spPr>
+        <p:style>
+          <a:lnRef idx="1">
+            <a:schemeClr val="accent1"/>
+          </a:lnRef>
+          <a:fillRef idx="3">
+            <a:schemeClr val="accent1"/>
+          </a:fillRef>
+          <a:effectRef idx="2">
+            <a:schemeClr val="accent1"/>
+          </a:effectRef>
+          <a:fontRef idx="minor">
+            <a:schemeClr val="lt1"/>
+          </a:fontRef>
+        </p:style>
+        <p:txBody>
+          <a:bodyPr rtlCol="0" anchor="ctr"/>
+          <a:lstStyle/>
+          <a:p>
+            <a:pPr algn="ctr"/>
+          </a:p>
+        </p:txBody>
+      </p:sp>
+      <p:sp>
+        <p:nvSpPr>
+          <p:cNvPr id="37" name="Rectangle 36"/>
+          <p:cNvSpPr/>
+          <p:nvPr/>
+        </p:nvSpPr>
+        <p:spPr>
+          <a:xfrm>
+            <a:off x="6309360" y="3712464"/>
+            <a:ext cx="73152" cy="1115568"/>
+          </a:xfrm>
+          <a:prstGeom prst="rect">
+            <a:avLst/>
+          </a:prstGeom>
+          <a:solidFill>
+            <a:srgbClr val="E3B341"/>
+          </a:solidFill>
+          <a:ln>
+            <a:noFill/>
+          </a:ln>
+        </p:spPr>
+        <p:style>
+          <a:lnRef idx="1">
+            <a:schemeClr val="accent1"/>
+          </a:lnRef>
+          <a:fillRef idx="3">
+            <a:schemeClr val="accent1"/>
+          </a:fillRef>
+          <a:effectRef idx="2">
+            <a:schemeClr val="accent1"/>
+          </a:effectRef>
+          <a:fontRef idx="minor">
+            <a:schemeClr val="lt1"/>
+          </a:fontRef>
+        </p:style>
+        <p:txBody>
+          <a:bodyPr rtlCol="0" anchor="ctr"/>
+          <a:lstStyle/>
+          <a:p>
+            <a:pPr algn="ctr"/>
+          </a:p>
+        </p:txBody>
+      </p:sp>
+      <p:sp>
+        <p:nvSpPr>
+          <p:cNvPr id="38" name="TextBox 37"/>
+          <p:cNvSpPr txBox="1"/>
+          <p:nvPr/>
+        </p:nvSpPr>
+        <p:spPr>
+          <a:xfrm>
+            <a:off x="6510528" y="3803904"/>
+            <a:ext cx="5120640" cy="347472"/>
+          </a:xfrm>
+          <a:prstGeom prst="rect">
+            <a:avLst/>
+          </a:prstGeom>
+          <a:noFill/>
+        </p:spPr>
+        <p:txBody>
+          <a:bodyPr wrap="square">
+            <a:spAutoFit/>
+          </a:bodyPr>
+          <a:lstStyle/>
+          <a:p>
+            <a:pPr algn="l"/>
+            <a:r>
+              <a:rPr sz="1200" b="1" i="0">
+                <a:solidFill>
+                  <a:srgbClr val="E3B341"/>
+                </a:solidFill>
+              </a:rPr>
+              <a:t>Mutation score reveals weak assertions</a:t>
+            </a:r>
+          </a:p>
+        </p:txBody>
+      </p:sp>
+      <p:sp>
+        <p:nvSpPr>
+          <p:cNvPr id="39" name="TextBox 38"/>
+          <p:cNvSpPr txBox="1"/>
+          <p:nvPr/>
+        </p:nvSpPr>
+        <p:spPr>
+          <a:xfrm>
+            <a:off x="6510528" y="4187952"/>
+            <a:ext cx="5120640" cy="566928"/>
+          </a:xfrm>
+          <a:prstGeom prst="rect">
+            <a:avLst/>
+          </a:prstGeom>
+          <a:noFill/>
+        </p:spPr>
+        <p:txBody>
+          <a:bodyPr wrap="square">
+            <a:spAutoFit/>
+          </a:bodyPr>
+          <a:lstStyle/>
+          <a:p>
+            <a:pPr algn="l"/>
+            <a:r>
+              <a:rPr sz="1000" b="0" i="0">
+                <a:solidFill>
+                  <a:srgbClr val="89939E"/>
+                </a:solidFill>
+              </a:rPr>
+              <a:t>Each surviving mutant pointed to a test that was too broad. Precision beats quantity.</a:t>
+            </a:r>
+          </a:p>
+        </p:txBody>
+      </p:sp>
+      <p:sp>
+        <p:nvSpPr>
+          <p:cNvPr id="40" name="Rectangle 39"/>
+          <p:cNvSpPr/>
+          <p:nvPr/>
+        </p:nvSpPr>
+        <p:spPr>
+          <a:xfrm>
+            <a:off x="6309360" y="4974336"/>
+            <a:ext cx="5440680" cy="1115568"/>
+          </a:xfrm>
+          <a:prstGeom prst="rect">
+            <a:avLst/>
+          </a:prstGeom>
+          <a:solidFill>
+            <a:srgbClr val="1C232C"/>
+          </a:solidFill>
+          <a:ln w="9525">
+            <a:solidFill>
+              <a:srgbClr val="30363D"/>
+            </a:solidFill>
+          </a:ln>
+        </p:spPr>
+        <p:style>
+          <a:lnRef idx="1">
+            <a:schemeClr val="accent1"/>
+          </a:lnRef>
+          <a:fillRef idx="3">
+            <a:schemeClr val="accent1"/>
+          </a:fillRef>
+          <a:effectRef idx="2">
+            <a:schemeClr val="accent1"/>
+          </a:effectRef>
+          <a:fontRef idx="minor">
+            <a:schemeClr val="lt1"/>
+          </a:fontRef>
+        </p:style>
+        <p:txBody>
+          <a:bodyPr rtlCol="0" anchor="ctr"/>
+          <a:lstStyle/>
+          <a:p>
+            <a:pPr algn="ctr"/>
+          </a:p>
+        </p:txBody>
+      </p:sp>
+      <p:sp>
+        <p:nvSpPr>
+          <p:cNvPr id="41" name="Rectangle 40"/>
+          <p:cNvSpPr/>
+          <p:nvPr/>
+        </p:nvSpPr>
+        <p:spPr>
+          <a:xfrm>
+            <a:off x="6309360" y="4974336"/>
+            <a:ext cx="73152" cy="1115568"/>
+          </a:xfrm>
+          <a:prstGeom prst="rect">
+            <a:avLst/>
+          </a:prstGeom>
+          <a:solidFill>
+            <a:srgbClr val="BC8CFF"/>
+          </a:solidFill>
+          <a:ln>
+            <a:noFill/>
+          </a:ln>
+        </p:spPr>
+        <p:style>
+          <a:lnRef idx="1">
+            <a:schemeClr val="accent1"/>
+          </a:lnRef>
+          <a:fillRef idx="3">
+            <a:schemeClr val="accent1"/>
+          </a:fillRef>
+          <a:effectRef idx="2">
+            <a:schemeClr val="accent1"/>
+          </a:effectRef>
+          <a:fontRef idx="minor">
+            <a:schemeClr val="lt1"/>
+          </a:fontRef>
+        </p:style>
+        <p:txBody>
+          <a:bodyPr rtlCol="0" anchor="ctr"/>
+          <a:lstStyle/>
+          <a:p>
+            <a:pPr algn="ctr"/>
+          </a:p>
+        </p:txBody>
+      </p:sp>
+      <p:sp>
+        <p:nvSpPr>
+          <p:cNvPr id="42" name="TextBox 41"/>
+          <p:cNvSpPr txBox="1"/>
+          <p:nvPr/>
+        </p:nvSpPr>
+        <p:spPr>
+          <a:xfrm>
+            <a:off x="6510528" y="5065776"/>
+            <a:ext cx="5120640" cy="347472"/>
+          </a:xfrm>
+          <a:prstGeom prst="rect">
+            <a:avLst/>
+          </a:prstGeom>
+          <a:noFill/>
+        </p:spPr>
+        <p:txBody>
+          <a:bodyPr wrap="square">
+            <a:spAutoFit/>
+          </a:bodyPr>
+          <a:lstStyle/>
+          <a:p>
+            <a:pPr algn="l"/>
+            <a:r>
+              <a:rPr sz="1200" b="1" i="0">
+                <a:solidFill>
+                  <a:srgbClr val="BC8CFF"/>
+                </a:solidFill>
+              </a:rPr>
+              <a:t>TUI apps need PTY — subprocess alone is not enough</a:t>
+            </a:r>
+          </a:p>
+        </p:txBody>
+      </p:sp>
+      <p:sp>
+        <p:nvSpPr>
+          <p:cNvPr id="43" name="TextBox 42"/>
+          <p:cNvSpPr txBox="1"/>
+          <p:nvPr/>
+        </p:nvSpPr>
+        <p:spPr>
+          <a:xfrm>
+            <a:off x="6510528" y="5449824"/>
+            <a:ext cx="5120640" cy="566928"/>
+          </a:xfrm>
+          <a:prstGeom prst="rect">
+            <a:avLst/>
+          </a:prstGeom>
+          <a:noFill/>
+        </p:spPr>
+        <p:txBody>
+          <a:bodyPr wrap="square">
+            <a:spAutoFit/>
+          </a:bodyPr>
+          <a:lstStyle/>
+          <a:p>
+            <a:pPr algn="l"/>
+            <a:r>
+              <a:rPr sz="1000" b="0" i="0">
+                <a:solidFill>
+                  <a:srgbClr val="89939E"/>
+                </a:solidFill>
+              </a:rPr>
+              <a:t>Without pty, 40% of CLI flags (--task, --event) would be completely untestable.</a:t>
+            </a:r>
+          </a:p>
+        </p:txBody>
+      </p:sp>
+    </p:spTree>
+  </p:cSld>
+  <p:clrMapOvr>
+    <a:masterClrMapping/>
+  </p:clrMapOvr>
+</p:sld>
+</file>
+
 <file path=ppt/slides/slide2.xml><?xml version="1.0" encoding="utf-8"?>
 <p:sld xmlns:a="http://schemas.openxmlformats.org/drawingml/2006/main" xmlns:p="http://schemas.openxmlformats.org/presentationml/2006/main" xmlns:r="http://schemas.openxmlformats.org/officeDocument/2006/relationships">
   <p:cSld>
@@ -20631,6 +22325,316 @@
                 </a:solidFill>
               </a:rPr>
               <a:t>MIT</a:t>
+            </a:r>
+          </a:p>
+        </p:txBody>
+      </p:sp>
+      <p:sp>
+        <p:nvSpPr>
+          <p:cNvPr id="42" name="Rectangle 41"/>
+          <p:cNvSpPr/>
+          <p:nvPr/>
+        </p:nvSpPr>
+        <p:spPr>
+          <a:xfrm>
+            <a:off x="320040" y="4773168"/>
+            <a:ext cx="5394960" cy="1746504"/>
+          </a:xfrm>
+          <a:prstGeom prst="rect">
+            <a:avLst/>
+          </a:prstGeom>
+          <a:solidFill>
+            <a:srgbClr val="161B22"/>
+          </a:solidFill>
+          <a:ln w="9525">
+            <a:solidFill>
+              <a:srgbClr val="30363D"/>
+            </a:solidFill>
+          </a:ln>
+        </p:spPr>
+        <p:style>
+          <a:lnRef idx="1">
+            <a:schemeClr val="accent1"/>
+          </a:lnRef>
+          <a:fillRef idx="3">
+            <a:schemeClr val="accent1"/>
+          </a:fillRef>
+          <a:effectRef idx="2">
+            <a:schemeClr val="accent1"/>
+          </a:effectRef>
+          <a:fontRef idx="minor">
+            <a:schemeClr val="lt1"/>
+          </a:fontRef>
+        </p:style>
+        <p:txBody>
+          <a:bodyPr rtlCol="0" anchor="ctr"/>
+          <a:lstStyle/>
+          <a:p>
+            <a:pPr algn="ctr"/>
+          </a:p>
+        </p:txBody>
+      </p:sp>
+      <p:sp>
+        <p:nvSpPr>
+          <p:cNvPr id="43" name="TextBox 42"/>
+          <p:cNvSpPr txBox="1"/>
+          <p:nvPr/>
+        </p:nvSpPr>
+        <p:spPr>
+          <a:xfrm>
+            <a:off x="502920" y="4892040"/>
+            <a:ext cx="5029200" cy="320040"/>
+          </a:xfrm>
+          <a:prstGeom prst="rect">
+            <a:avLst/>
+          </a:prstGeom>
+          <a:noFill/>
+        </p:spPr>
+        <p:txBody>
+          <a:bodyPr wrap="square">
+            <a:spAutoFit/>
+          </a:bodyPr>
+          <a:lstStyle/>
+          <a:p>
+            <a:pPr algn="l"/>
+            <a:r>
+              <a:rPr sz="1200" b="1" i="0">
+                <a:solidFill>
+                  <a:srgbClr val="58A6FF"/>
+                </a:solidFill>
+              </a:rPr>
+              <a:t>Typical Users</a:t>
+            </a:r>
+          </a:p>
+        </p:txBody>
+      </p:sp>
+      <p:sp>
+        <p:nvSpPr>
+          <p:cNvPr id="44" name="Rectangle 43"/>
+          <p:cNvSpPr/>
+          <p:nvPr/>
+        </p:nvSpPr>
+        <p:spPr>
+          <a:xfrm>
+            <a:off x="502920" y="5430621"/>
+            <a:ext cx="91440" cy="91440"/>
+          </a:xfrm>
+          <a:prstGeom prst="rect">
+            <a:avLst/>
+          </a:prstGeom>
+          <a:solidFill>
+            <a:srgbClr val="58A6FF"/>
+          </a:solidFill>
+          <a:ln>
+            <a:noFill/>
+          </a:ln>
+        </p:spPr>
+        <p:style>
+          <a:lnRef idx="1">
+            <a:schemeClr val="accent1"/>
+          </a:lnRef>
+          <a:fillRef idx="3">
+            <a:schemeClr val="accent1"/>
+          </a:fillRef>
+          <a:effectRef idx="2">
+            <a:schemeClr val="accent1"/>
+          </a:effectRef>
+          <a:fontRef idx="minor">
+            <a:schemeClr val="lt1"/>
+          </a:fontRef>
+        </p:style>
+        <p:txBody>
+          <a:bodyPr rtlCol="0" anchor="ctr"/>
+          <a:lstStyle/>
+          <a:p>
+            <a:pPr algn="ctr"/>
+          </a:p>
+        </p:txBody>
+      </p:sp>
+      <p:sp>
+        <p:nvSpPr>
+          <p:cNvPr id="45" name="TextBox 44"/>
+          <p:cNvSpPr txBox="1"/>
+          <p:nvPr/>
+        </p:nvSpPr>
+        <p:spPr>
+          <a:xfrm>
+            <a:off x="704088" y="5257800"/>
+            <a:ext cx="4828032" cy="384048"/>
+          </a:xfrm>
+          <a:prstGeom prst="rect">
+            <a:avLst/>
+          </a:prstGeom>
+          <a:noFill/>
+        </p:spPr>
+        <p:txBody>
+          <a:bodyPr wrap="square">
+            <a:spAutoFit/>
+          </a:bodyPr>
+          <a:lstStyle/>
+          <a:p>
+            <a:pPr algn="l"/>
+            <a:r>
+              <a:rPr sz="1100" b="0" i="0">
+                <a:solidFill>
+                  <a:srgbClr val="89939E"/>
+                </a:solidFill>
+              </a:rPr>
+              <a:t>Developers &amp; power users who prefer terminal tools</a:t>
+            </a:r>
+          </a:p>
+        </p:txBody>
+      </p:sp>
+      <p:sp>
+        <p:nvSpPr>
+          <p:cNvPr id="46" name="Rectangle 45"/>
+          <p:cNvSpPr/>
+          <p:nvPr/>
+        </p:nvSpPr>
+        <p:spPr>
+          <a:xfrm>
+            <a:off x="502920" y="5814669"/>
+            <a:ext cx="91440" cy="91440"/>
+          </a:xfrm>
+          <a:prstGeom prst="rect">
+            <a:avLst/>
+          </a:prstGeom>
+          <a:solidFill>
+            <a:srgbClr val="58A6FF"/>
+          </a:solidFill>
+          <a:ln>
+            <a:noFill/>
+          </a:ln>
+        </p:spPr>
+        <p:style>
+          <a:lnRef idx="1">
+            <a:schemeClr val="accent1"/>
+          </a:lnRef>
+          <a:fillRef idx="3">
+            <a:schemeClr val="accent1"/>
+          </a:fillRef>
+          <a:effectRef idx="2">
+            <a:schemeClr val="accent1"/>
+          </a:effectRef>
+          <a:fontRef idx="minor">
+            <a:schemeClr val="lt1"/>
+          </a:fontRef>
+        </p:style>
+        <p:txBody>
+          <a:bodyPr rtlCol="0" anchor="ctr"/>
+          <a:lstStyle/>
+          <a:p>
+            <a:pPr algn="ctr"/>
+          </a:p>
+        </p:txBody>
+      </p:sp>
+      <p:sp>
+        <p:nvSpPr>
+          <p:cNvPr id="47" name="TextBox 46"/>
+          <p:cNvSpPr txBox="1"/>
+          <p:nvPr/>
+        </p:nvSpPr>
+        <p:spPr>
+          <a:xfrm>
+            <a:off x="704088" y="5641848"/>
+            <a:ext cx="4828032" cy="384048"/>
+          </a:xfrm>
+          <a:prstGeom prst="rect">
+            <a:avLst/>
+          </a:prstGeom>
+          <a:noFill/>
+        </p:spPr>
+        <p:txBody>
+          <a:bodyPr wrap="square">
+            <a:spAutoFit/>
+          </a:bodyPr>
+          <a:lstStyle/>
+          <a:p>
+            <a:pPr algn="l"/>
+            <a:r>
+              <a:rPr sz="1100" b="0" i="0">
+                <a:solidFill>
+                  <a:srgbClr val="89939E"/>
+                </a:solidFill>
+              </a:rPr>
+              <a:t>Users who want lightweight alternatives to Google/Apple Calendar</a:t>
+            </a:r>
+          </a:p>
+        </p:txBody>
+      </p:sp>
+      <p:sp>
+        <p:nvSpPr>
+          <p:cNvPr id="48" name="Rectangle 47"/>
+          <p:cNvSpPr/>
+          <p:nvPr/>
+        </p:nvSpPr>
+        <p:spPr>
+          <a:xfrm>
+            <a:off x="502920" y="6198717"/>
+            <a:ext cx="91440" cy="91440"/>
+          </a:xfrm>
+          <a:prstGeom prst="rect">
+            <a:avLst/>
+          </a:prstGeom>
+          <a:solidFill>
+            <a:srgbClr val="58A6FF"/>
+          </a:solidFill>
+          <a:ln>
+            <a:noFill/>
+          </a:ln>
+        </p:spPr>
+        <p:style>
+          <a:lnRef idx="1">
+            <a:schemeClr val="accent1"/>
+          </a:lnRef>
+          <a:fillRef idx="3">
+            <a:schemeClr val="accent1"/>
+          </a:fillRef>
+          <a:effectRef idx="2">
+            <a:schemeClr val="accent1"/>
+          </a:effectRef>
+          <a:fontRef idx="minor">
+            <a:schemeClr val="lt1"/>
+          </a:fontRef>
+        </p:style>
+        <p:txBody>
+          <a:bodyPr rtlCol="0" anchor="ctr"/>
+          <a:lstStyle/>
+          <a:p>
+            <a:pPr algn="ctr"/>
+          </a:p>
+        </p:txBody>
+      </p:sp>
+      <p:sp>
+        <p:nvSpPr>
+          <p:cNvPr id="49" name="TextBox 48"/>
+          <p:cNvSpPr txBox="1"/>
+          <p:nvPr/>
+        </p:nvSpPr>
+        <p:spPr>
+          <a:xfrm>
+            <a:off x="704088" y="6025896"/>
+            <a:ext cx="4828032" cy="384048"/>
+          </a:xfrm>
+          <a:prstGeom prst="rect">
+            <a:avLst/>
+          </a:prstGeom>
+          <a:noFill/>
+        </p:spPr>
+        <p:txBody>
+          <a:bodyPr wrap="square">
+            <a:spAutoFit/>
+          </a:bodyPr>
+          <a:lstStyle/>
+          <a:p>
+            <a:pPr algn="l"/>
+            <a:r>
+              <a:rPr sz="1100" b="0" i="0">
+                <a:solidFill>
+                  <a:srgbClr val="89939E"/>
+                </a:solidFill>
+              </a:rPr>
+              <a:t>Linux / macOS users comfortable with keyboard-only workflows</a:t>
             </a:r>
           </a:p>
         </p:txBody>

</xml_diff>